<commit_message>
presentaciones: comparacion de caminos + hitos + quien financia que (Omar); ventaja competitiva + red del plan + reencuadre (papas)
Omar (deck_o3.js): agrega el cambio de plan mecanico (Baoli) -> EDR como
acierto que puso on-track, la linea de hitos con fecha (ago -> hoy), y el
slide 'quien pone que' (NRE + computo = maje; reparar MT 122 +
salario/confianza = inversion de Montasa). El pedido de computo se
reencuadra: lo reduje a 500 y lo pago yo; a Montasa solo se le pide
recuperar un activo suyo.

Papas (deck_papas.js): agrega 'esto no es un proyecto cualquiera' (las
habilidades que valen en el mercado laboral), 'el plan tiene red' (si no
sale, abre un trabajo de ingenieria en Europa) y 'por que a veces no nos
entendemos' (puente: lenguajes distintos, no incoherencia).

Co-Authored-By: Claude Opus 4.8 <noreply@anthropic.com>
Claude-Session: https://claude.ai/code/session_01KLG9KVbY9Gwk6b8JaDsbqA
</commit_message>
<xml_diff>
--- a/presentaciones/TaTa_Para_mis_papas.pptx
+++ b/presentaciones/TaTa_Para_mis_papas.pptx
@@ -12,9 +12,12 @@
     <p:sldId id="260" r:id="rId6"/>
     <p:sldId id="261" r:id="rId7"/>
     <p:sldId id="262" r:id="rId8"/>
+    <p:sldId id="263" r:id="rId9"/>
+    <p:sldId id="264" r:id="rId10"/>
+    <p:sldId id="265" r:id="rId11"/>
   </p:sldIdLst>
   <p:notesMasterIdLst>
-    <p:notesMasterId r:id="rId9"/>
+    <p:notesMasterId r:id="rId12"/>
   </p:notesMasterIdLst>
   <p:sldSz cx="12192000" cy="6858000"/>
   <p:notesSz cx="6858000" cy="12192000"/>
@@ -550,6 +553,94 @@
 </p:notes>
 </file>
 
+<file path=ppt/notesSlides/notesSlide10.xml><?xml version="1.0" encoding="utf-8"?>
+<p:notes xmlns:a="http://schemas.openxmlformats.org/drawingml/2006/main" xmlns:r="http://schemas.openxmlformats.org/officeDocument/2006/relationships" xmlns:p="http://schemas.openxmlformats.org/presentationml/2006/main">
+  <p:cSld>
+    <p:spTree>
+      <p:nvGrpSpPr>
+        <p:cNvPr id="1" name=""/>
+        <p:cNvGrpSpPr/>
+        <p:nvPr/>
+      </p:nvGrpSpPr>
+      <p:grpSpPr>
+        <a:xfrm>
+          <a:off x="0" y="0"/>
+          <a:ext cx="0" cy="0"/>
+          <a:chOff x="0" y="0"/>
+          <a:chExt cx="0" cy="0"/>
+        </a:xfrm>
+      </p:grpSpPr>
+      <p:sp>
+        <p:nvSpPr>
+          <p:cNvPr id="2" name="Slide Image Placeholder 1"/>
+          <p:cNvSpPr>
+            <a:spLocks noGrp="1" noRot="1" noChangeAspect="1"/>
+          </p:cNvSpPr>
+          <p:nvPr>
+            <p:ph type="sldImg"/>
+          </p:nvPr>
+        </p:nvSpPr>
+        <p:spPr/>
+      </p:sp>
+      <p:sp>
+        <p:nvSpPr>
+          <p:cNvPr id="3" name="Notes Placeholder 2"/>
+          <p:cNvSpPr>
+            <a:spLocks noGrp="1"/>
+          </p:cNvSpPr>
+          <p:nvPr>
+            <p:ph type="body" idx="1"/>
+          </p:nvPr>
+        </p:nvSpPr>
+        <p:spPr/>
+        <p:txBody>
+          <a:bodyPr/>
+          <a:lstStyle/>
+          <a:p>
+            <a:r>
+              <a:rPr lang="en-US" dirty="0"/>
+              <a:t>Cerrar tranquilo. No prometer fechas. El mensaje: trabajo real, respaldado, con red, en progreso.</a:t>
+            </a:r>
+            <a:endParaRPr lang="en-US" dirty="0"/>
+          </a:p>
+        </p:txBody>
+      </p:sp>
+      <p:sp>
+        <p:nvSpPr>
+          <p:cNvPr id="4" name="Slide Number Placeholder 3"/>
+          <p:cNvSpPr>
+            <a:spLocks noGrp="1"/>
+          </p:cNvSpPr>
+          <p:nvPr>
+            <p:ph type="sldNum" sz="quarter" idx="10"/>
+          </p:nvPr>
+        </p:nvSpPr>
+        <p:spPr/>
+        <p:txBody>
+          <a:bodyPr/>
+          <a:lstStyle/>
+          <a:p>
+            <a:fld id="{F7021451-1387-4CA6-816F-3879F97B5CBC}" type="slidenum">
+              <a:rPr lang="en-US"/>
+              <a:t>10</a:t>
+            </a:fld>
+            <a:endParaRPr lang="en-US"/>
+          </a:p>
+        </p:txBody>
+      </p:sp>
+    </p:spTree>
+    <p:extLst>
+      <p:ext uri="{BB962C8B-B14F-4D97-AF65-F5344CB8AC3E}">
+        <p14:creationId xmlns:p14="http://schemas.microsoft.com/office/powerpoint/2010/main" val="1024086991"/>
+      </p:ext>
+    </p:extLst>
+  </p:cSld>
+  <p:clrMapOvr>
+    <a:masterClrMapping/>
+  </p:clrMapOvr>
+</p:notes>
+</file>
+
 <file path=ppt/notesSlides/notesSlide2.xml><?xml version="1.0" encoding="utf-8"?>
 <p:notes xmlns:a="http://schemas.openxmlformats.org/drawingml/2006/main" xmlns:r="http://schemas.openxmlformats.org/officeDocument/2006/relationships" xmlns:p="http://schemas.openxmlformats.org/presentationml/2006/main">
   <p:cSld>
@@ -1036,7 +1127,7 @@
           <a:p>
             <a:r>
               <a:rPr lang="en-US" dirty="0"/>
-              <a:t>Cerrar tranquilo. No prometer fechas. El mensaje: trabajo real, respaldado, en progreso.</a:t>
+              <a:t/>
             </a:r>
             <a:endParaRPr lang="en-US" dirty="0"/>
           </a:p>
@@ -1060,6 +1151,182 @@
             <a:fld id="{F7021451-1387-4CA6-816F-3879F97B5CBC}" type="slidenum">
               <a:rPr lang="en-US"/>
               <a:t>7</a:t>
+            </a:fld>
+            <a:endParaRPr lang="en-US"/>
+          </a:p>
+        </p:txBody>
+      </p:sp>
+    </p:spTree>
+    <p:extLst>
+      <p:ext uri="{BB962C8B-B14F-4D97-AF65-F5344CB8AC3E}">
+        <p14:creationId xmlns:p14="http://schemas.microsoft.com/office/powerpoint/2010/main" val="1024086991"/>
+      </p:ext>
+    </p:extLst>
+  </p:cSld>
+  <p:clrMapOvr>
+    <a:masterClrMapping/>
+  </p:clrMapOvr>
+</p:notes>
+</file>
+
+<file path=ppt/notesSlides/notesSlide8.xml><?xml version="1.0" encoding="utf-8"?>
+<p:notes xmlns:a="http://schemas.openxmlformats.org/drawingml/2006/main" xmlns:r="http://schemas.openxmlformats.org/officeDocument/2006/relationships" xmlns:p="http://schemas.openxmlformats.org/presentationml/2006/main">
+  <p:cSld>
+    <p:spTree>
+      <p:nvGrpSpPr>
+        <p:cNvPr id="1" name=""/>
+        <p:cNvGrpSpPr/>
+        <p:nvPr/>
+      </p:nvGrpSpPr>
+      <p:grpSpPr>
+        <a:xfrm>
+          <a:off x="0" y="0"/>
+          <a:ext cx="0" cy="0"/>
+          <a:chOff x="0" y="0"/>
+          <a:chExt cx="0" cy="0"/>
+        </a:xfrm>
+      </p:grpSpPr>
+      <p:sp>
+        <p:nvSpPr>
+          <p:cNvPr id="2" name="Slide Image Placeholder 1"/>
+          <p:cNvSpPr>
+            <a:spLocks noGrp="1" noRot="1" noChangeAspect="1"/>
+          </p:cNvSpPr>
+          <p:nvPr>
+            <p:ph type="sldImg"/>
+          </p:nvPr>
+        </p:nvSpPr>
+        <p:spPr/>
+      </p:sp>
+      <p:sp>
+        <p:nvSpPr>
+          <p:cNvPr id="3" name="Notes Placeholder 2"/>
+          <p:cNvSpPr>
+            <a:spLocks noGrp="1"/>
+          </p:cNvSpPr>
+          <p:nvPr>
+            <p:ph type="body" idx="1"/>
+          </p:nvPr>
+        </p:nvSpPr>
+        <p:spPr/>
+        <p:txBody>
+          <a:bodyPr/>
+          <a:lstStyle/>
+          <a:p>
+            <a:r>
+              <a:rPr lang="en-US" dirty="0"/>
+              <a:t>Este slide contesta directo la angustia de "conseguia trabajo". La respuesta: esto ES el camino al trabajo, y a uno mejor.</a:t>
+            </a:r>
+            <a:endParaRPr lang="en-US" dirty="0"/>
+          </a:p>
+        </p:txBody>
+      </p:sp>
+      <p:sp>
+        <p:nvSpPr>
+          <p:cNvPr id="4" name="Slide Number Placeholder 3"/>
+          <p:cNvSpPr>
+            <a:spLocks noGrp="1"/>
+          </p:cNvSpPr>
+          <p:nvPr>
+            <p:ph type="sldNum" sz="quarter" idx="10"/>
+          </p:nvPr>
+        </p:nvSpPr>
+        <p:spPr/>
+        <p:txBody>
+          <a:bodyPr/>
+          <a:lstStyle/>
+          <a:p>
+            <a:fld id="{F7021451-1387-4CA6-816F-3879F97B5CBC}" type="slidenum">
+              <a:rPr lang="en-US"/>
+              <a:t>8</a:t>
+            </a:fld>
+            <a:endParaRPr lang="en-US"/>
+          </a:p>
+        </p:txBody>
+      </p:sp>
+    </p:spTree>
+    <p:extLst>
+      <p:ext uri="{BB962C8B-B14F-4D97-AF65-F5344CB8AC3E}">
+        <p14:creationId xmlns:p14="http://schemas.microsoft.com/office/powerpoint/2010/main" val="1024086991"/>
+      </p:ext>
+    </p:extLst>
+  </p:cSld>
+  <p:clrMapOvr>
+    <a:masterClrMapping/>
+  </p:clrMapOvr>
+</p:notes>
+</file>
+
+<file path=ppt/notesSlides/notesSlide9.xml><?xml version="1.0" encoding="utf-8"?>
+<p:notes xmlns:a="http://schemas.openxmlformats.org/drawingml/2006/main" xmlns:r="http://schemas.openxmlformats.org/officeDocument/2006/relationships" xmlns:p="http://schemas.openxmlformats.org/presentationml/2006/main">
+  <p:cSld>
+    <p:spTree>
+      <p:nvGrpSpPr>
+        <p:cNvPr id="1" name=""/>
+        <p:cNvGrpSpPr/>
+        <p:nvPr/>
+      </p:nvGrpSpPr>
+      <p:grpSpPr>
+        <a:xfrm>
+          <a:off x="0" y="0"/>
+          <a:ext cx="0" cy="0"/>
+          <a:chOff x="0" y="0"/>
+          <a:chExt cx="0" cy="0"/>
+        </a:xfrm>
+      </p:grpSpPr>
+      <p:sp>
+        <p:nvSpPr>
+          <p:cNvPr id="2" name="Slide Image Placeholder 1"/>
+          <p:cNvSpPr>
+            <a:spLocks noGrp="1" noRot="1" noChangeAspect="1"/>
+          </p:cNvSpPr>
+          <p:nvPr>
+            <p:ph type="sldImg"/>
+          </p:nvPr>
+        </p:nvSpPr>
+        <p:spPr/>
+      </p:sp>
+      <p:sp>
+        <p:nvSpPr>
+          <p:cNvPr id="3" name="Notes Placeholder 2"/>
+          <p:cNvSpPr>
+            <a:spLocks noGrp="1"/>
+          </p:cNvSpPr>
+          <p:nvPr>
+            <p:ph type="body" idx="1"/>
+          </p:nvPr>
+        </p:nvSpPr>
+        <p:spPr/>
+        <p:txBody>
+          <a:bodyPr/>
+          <a:lstStyle/>
+          <a:p>
+            <a:r>
+              <a:rPr lang="en-US" dirty="0"/>
+              <a:t>El slide delicado. Puente, no reclamo: valida lo mio sin acusar. La analogia del mecanico aterriza en esta familia. Pedir confianza, no razon.</a:t>
+            </a:r>
+            <a:endParaRPr lang="en-US" dirty="0"/>
+          </a:p>
+        </p:txBody>
+      </p:sp>
+      <p:sp>
+        <p:nvSpPr>
+          <p:cNvPr id="4" name="Slide Number Placeholder 3"/>
+          <p:cNvSpPr>
+            <a:spLocks noGrp="1"/>
+          </p:cNvSpPr>
+          <p:nvPr>
+            <p:ph type="sldNum" sz="quarter" idx="10"/>
+          </p:nvPr>
+        </p:nvSpPr>
+        <p:spPr/>
+        <p:txBody>
+          <a:bodyPr/>
+          <a:lstStyle/>
+          <a:p>
+            <a:fld id="{F7021451-1387-4CA6-816F-3879F97B5CBC}" type="slidenum">
+              <a:rPr lang="en-US"/>
+              <a:t>9</a:t>
             </a:fld>
             <a:endParaRPr lang="en-US"/>
           </a:p>
@@ -1577,6 +1844,201 @@
 </p:sld>
 </file>
 
+<file path=ppt/slides/slide10.xml><?xml version="1.0" encoding="utf-8"?>
+<p:sld xmlns:a="http://schemas.openxmlformats.org/drawingml/2006/main" xmlns:r="http://schemas.openxmlformats.org/officeDocument/2006/relationships" xmlns:p="http://schemas.openxmlformats.org/presentationml/2006/main">
+  <p:cSld name="Slide 10">
+    <p:bg>
+      <p:bgPr>
+        <a:solidFill>
+          <a:srgbClr val="14171C"/>
+        </a:solidFill>
+      </p:bgPr>
+    </p:bg>
+    <p:spTree>
+      <p:nvGrpSpPr>
+        <p:cNvPr id="1" name=""/>
+        <p:cNvGrpSpPr/>
+        <p:nvPr/>
+      </p:nvGrpSpPr>
+      <p:grpSpPr>
+        <a:xfrm>
+          <a:off x="0" y="0"/>
+          <a:ext cx="0" cy="0"/>
+          <a:chOff x="0" y="0"/>
+          <a:chExt cx="0" cy="0"/>
+        </a:xfrm>
+      </p:grpSpPr>
+      <p:sp>
+        <p:nvSpPr>
+          <p:cNvPr id="2" name="Shape 0"/>
+          <p:cNvSpPr/>
+          <p:nvPr/>
+        </p:nvSpPr>
+        <p:spPr>
+          <a:xfrm>
+            <a:off x="914400" y="2514600"/>
+            <a:ext cx="1463040" cy="45720"/>
+          </a:xfrm>
+          <a:prstGeom prst="rect">
+            <a:avLst/>
+          </a:prstGeom>
+          <a:solidFill>
+            <a:srgbClr val="E0A82E"/>
+          </a:solidFill>
+          <a:ln/>
+        </p:spPr>
+      </p:sp>
+      <p:sp>
+        <p:nvSpPr>
+          <p:cNvPr id="3" name="Text 1"/>
+          <p:cNvSpPr/>
+          <p:nvPr/>
+        </p:nvSpPr>
+        <p:spPr>
+          <a:xfrm>
+            <a:off x="868680" y="1600200"/>
+            <a:ext cx="10058400" cy="1463040"/>
+          </a:xfrm>
+          <a:prstGeom prst="rect">
+            <a:avLst/>
+          </a:prstGeom>
+          <a:noFill/>
+          <a:ln/>
+        </p:spPr>
+        <p:txBody>
+          <a:bodyPr wrap="square" lIns="0" tIns="0" rIns="0" bIns="0" rtlCol="0" anchor="ctr"/>
+          <a:lstStyle/>
+          <a:p>
+            <a:pPr indent="0" marL="0">
+              <a:lnSpc>
+                <a:spcPts val="4400"/>
+              </a:lnSpc>
+              <a:buNone/>
+            </a:pPr>
+            <a:r>
+              <a:rPr lang="en-US" sz="3600" b="1" dirty="0">
+                <a:solidFill>
+                  <a:srgbClr val="ECEBE6"/>
+                </a:solidFill>
+                <a:latin typeface="Cambria" pitchFamily="34" charset="0"/>
+                <a:ea typeface="Cambria" pitchFamily="34" charset="-122"/>
+                <a:cs typeface="Cambria" pitchFamily="34" charset="-120"/>
+              </a:rPr>
+              <a:t>Esto es lo que estoy</a:t>
+            </a:r>
+            <a:endParaRPr lang="en-US" sz="3600" dirty="0"/>
+          </a:p>
+          <a:p>
+            <a:pPr indent="0" marL="0">
+              <a:lnSpc>
+                <a:spcPts val="4400"/>
+              </a:lnSpc>
+              <a:buNone/>
+            </a:pPr>
+            <a:r>
+              <a:rPr lang="en-US" sz="3600" b="1" dirty="0">
+                <a:solidFill>
+                  <a:srgbClr val="ECEBE6"/>
+                </a:solidFill>
+                <a:latin typeface="Cambria" pitchFamily="34" charset="0"/>
+                <a:ea typeface="Cambria" pitchFamily="34" charset="-122"/>
+                <a:cs typeface="Cambria" pitchFamily="34" charset="-120"/>
+              </a:rPr>
+              <a:t>construyendo.</a:t>
+            </a:r>
+            <a:endParaRPr lang="en-US" sz="3600" dirty="0"/>
+          </a:p>
+        </p:txBody>
+      </p:sp>
+      <p:sp>
+        <p:nvSpPr>
+          <p:cNvPr id="4" name="Text 2"/>
+          <p:cNvSpPr/>
+          <p:nvPr/>
+        </p:nvSpPr>
+        <p:spPr>
+          <a:xfrm>
+            <a:off x="914400" y="3429000"/>
+            <a:ext cx="9875520" cy="1097280"/>
+          </a:xfrm>
+          <a:prstGeom prst="rect">
+            <a:avLst/>
+          </a:prstGeom>
+          <a:noFill/>
+          <a:ln/>
+        </p:spPr>
+        <p:txBody>
+          <a:bodyPr wrap="square" lIns="0" tIns="0" rIns="0" bIns="0" rtlCol="0" anchor="ctr"/>
+          <a:lstStyle/>
+          <a:p>
+            <a:pPr indent="0" marL="0">
+              <a:lnSpc>
+                <a:spcPts val="2400"/>
+              </a:lnSpc>
+              <a:buNone/>
+            </a:pPr>
+            <a:r>
+              <a:rPr lang="en-US" sz="1600" dirty="0">
+                <a:solidFill>
+                  <a:srgbClr val="8B949E"/>
+                </a:solidFill>
+                <a:latin typeface="Calibri" pitchFamily="34" charset="0"/>
+                <a:ea typeface="Calibri" pitchFamily="34" charset="-122"/>
+                <a:cs typeface="Calibri" pitchFamily="34" charset="-120"/>
+              </a:rPr>
+              <a:t>Toma tiempo porque nadie lo ha hecho antes en estos equipos. Pero ya funciona en mi mesa, la empresa está detrás, y si no sale, me abre otra puerta.</a:t>
+            </a:r>
+            <a:endParaRPr lang="en-US" sz="1600" dirty="0"/>
+          </a:p>
+        </p:txBody>
+      </p:sp>
+      <p:sp>
+        <p:nvSpPr>
+          <p:cNvPr id="5" name="Text 3"/>
+          <p:cNvSpPr/>
+          <p:nvPr/>
+        </p:nvSpPr>
+        <p:spPr>
+          <a:xfrm>
+            <a:off x="914400" y="4572000"/>
+            <a:ext cx="9875520" cy="457200"/>
+          </a:xfrm>
+          <a:prstGeom prst="rect">
+            <a:avLst/>
+          </a:prstGeom>
+          <a:noFill/>
+          <a:ln/>
+        </p:spPr>
+        <p:txBody>
+          <a:bodyPr wrap="square" lIns="0" tIns="0" rIns="0" bIns="0" rtlCol="0" anchor="ctr"/>
+          <a:lstStyle/>
+          <a:p>
+            <a:pPr indent="0" marL="0">
+              <a:buNone/>
+            </a:pPr>
+            <a:r>
+              <a:rPr lang="en-US" sz="1700" b="1" dirty="0">
+                <a:solidFill>
+                  <a:srgbClr val="E0A82E"/>
+                </a:solidFill>
+                <a:latin typeface="Calibri" pitchFamily="34" charset="0"/>
+                <a:ea typeface="Calibri" pitchFamily="34" charset="-122"/>
+                <a:cs typeface="Calibri" pitchFamily="34" charset="-120"/>
+              </a:rPr>
+              <a:t>De cualquier forma, no es tiempo perdido.</a:t>
+            </a:r>
+            <a:endParaRPr lang="en-US" sz="1700" dirty="0"/>
+          </a:p>
+        </p:txBody>
+      </p:sp>
+    </p:spTree>
+  </p:cSld>
+  <p:clrMapOvr>
+    <a:masterClrMapping/>
+  </p:clrMapOvr>
+</p:sld>
+</file>
+
 <file path=ppt/slides/slide2.xml><?xml version="1.0" encoding="utf-8"?>
 <p:sld xmlns:a="http://schemas.openxmlformats.org/drawingml/2006/main" xmlns:r="http://schemas.openxmlformats.org/officeDocument/2006/relationships" xmlns:p="http://schemas.openxmlformats.org/presentationml/2006/main">
   <p:cSld name="Slide 2">
@@ -4040,6 +4502,731 @@
     <p:bg>
       <p:bgPr>
         <a:solidFill>
+          <a:srgbClr val="F7F6F2"/>
+        </a:solidFill>
+      </p:bgPr>
+    </p:bg>
+    <p:spTree>
+      <p:nvGrpSpPr>
+        <p:cNvPr id="1" name=""/>
+        <p:cNvGrpSpPr/>
+        <p:nvPr/>
+      </p:nvGrpSpPr>
+      <p:grpSpPr>
+        <a:xfrm>
+          <a:off x="0" y="0"/>
+          <a:ext cx="0" cy="0"/>
+          <a:chOff x="0" y="0"/>
+          <a:chExt cx="0" cy="0"/>
+        </a:xfrm>
+      </p:grpSpPr>
+      <p:sp>
+        <p:nvSpPr>
+          <p:cNvPr id="2" name="Text 0"/>
+          <p:cNvSpPr/>
+          <p:nvPr/>
+        </p:nvSpPr>
+        <p:spPr>
+          <a:xfrm>
+            <a:off x="640080" y="457200"/>
+            <a:ext cx="10881360" cy="822960"/>
+          </a:xfrm>
+          <a:prstGeom prst="rect">
+            <a:avLst/>
+          </a:prstGeom>
+          <a:noFill/>
+          <a:ln/>
+        </p:spPr>
+        <p:txBody>
+          <a:bodyPr wrap="square" lIns="0" tIns="0" rIns="0" bIns="0" rtlCol="0" anchor="ctr"/>
+          <a:lstStyle/>
+          <a:p>
+            <a:pPr indent="0" marL="0">
+              <a:buNone/>
+            </a:pPr>
+            <a:r>
+              <a:rPr lang="en-US" sz="3200" b="1" dirty="0">
+                <a:solidFill>
+                  <a:srgbClr val="1A1D23"/>
+                </a:solidFill>
+                <a:latin typeface="Cambria" pitchFamily="34" charset="0"/>
+                <a:ea typeface="Cambria" pitchFamily="34" charset="-122"/>
+                <a:cs typeface="Cambria" pitchFamily="34" charset="-120"/>
+              </a:rPr>
+              <a:t>Esto no es un proyecto cualquiera</a:t>
+            </a:r>
+            <a:endParaRPr lang="en-US" sz="3200" dirty="0"/>
+          </a:p>
+        </p:txBody>
+      </p:sp>
+      <p:sp>
+        <p:nvSpPr>
+          <p:cNvPr id="3" name="Text 1"/>
+          <p:cNvSpPr/>
+          <p:nvPr/>
+        </p:nvSpPr>
+        <p:spPr>
+          <a:xfrm>
+            <a:off x="640080" y="1234440"/>
+            <a:ext cx="10881360" cy="411480"/>
+          </a:xfrm>
+          <a:prstGeom prst="rect">
+            <a:avLst/>
+          </a:prstGeom>
+          <a:noFill/>
+          <a:ln/>
+        </p:spPr>
+        <p:txBody>
+          <a:bodyPr wrap="square" lIns="0" tIns="0" rIns="0" bIns="0" rtlCol="0" anchor="ctr"/>
+          <a:lstStyle/>
+          <a:p>
+            <a:pPr indent="0" marL="0">
+              <a:buNone/>
+            </a:pPr>
+            <a:r>
+              <a:rPr lang="en-US" sz="1500" dirty="0">
+                <a:solidFill>
+                  <a:srgbClr val="5B6470"/>
+                </a:solidFill>
+                <a:latin typeface="Calibri" pitchFamily="34" charset="0"/>
+                <a:ea typeface="Calibri" pitchFamily="34" charset="-122"/>
+                <a:cs typeface="Calibri" pitchFamily="34" charset="-120"/>
+              </a:rPr>
+              <a:t>Es experiencia de ingeniería que vale en el mercado laboral del mundo</a:t>
+            </a:r>
+            <a:endParaRPr lang="en-US" sz="1500" dirty="0"/>
+          </a:p>
+        </p:txBody>
+      </p:sp>
+      <p:sp>
+        <p:nvSpPr>
+          <p:cNvPr id="4" name="Shape 2"/>
+          <p:cNvSpPr/>
+          <p:nvPr/>
+        </p:nvSpPr>
+        <p:spPr>
+          <a:xfrm>
+            <a:off x="640080" y="1783080"/>
+            <a:ext cx="10881360" cy="914400"/>
+          </a:xfrm>
+          <a:prstGeom prst="roundRect">
+            <a:avLst>
+              <a:gd name="adj" fmla="val 10000"/>
+            </a:avLst>
+          </a:prstGeom>
+          <a:solidFill>
+            <a:srgbClr val="FFFFFF"/>
+          </a:solidFill>
+          <a:ln/>
+          <a:effectLst>
+            <a:outerShdw sx="100000" sy="100000" kx="0" ky="0" algn="bl" rotWithShape="0" blurRad="127000" dist="25400" dir="5400000">
+              <a:srgbClr val="000000">
+                <a:alpha val="18000"/>
+              </a:srgbClr>
+            </a:outerShdw>
+          </a:effectLst>
+        </p:spPr>
+      </p:sp>
+      <p:sp>
+        <p:nvSpPr>
+          <p:cNvPr id="5" name="Text 3"/>
+          <p:cNvSpPr/>
+          <p:nvPr/>
+        </p:nvSpPr>
+        <p:spPr>
+          <a:xfrm>
+            <a:off x="1005840" y="1783080"/>
+            <a:ext cx="10149840" cy="914400"/>
+          </a:xfrm>
+          <a:prstGeom prst="rect">
+            <a:avLst/>
+          </a:prstGeom>
+          <a:noFill/>
+          <a:ln/>
+        </p:spPr>
+        <p:txBody>
+          <a:bodyPr wrap="square" lIns="0" tIns="0" rIns="0" bIns="0" rtlCol="0" anchor="ctr"/>
+          <a:lstStyle/>
+          <a:p>
+            <a:pPr indent="0" marL="0">
+              <a:buNone/>
+            </a:pPr>
+            <a:r>
+              <a:rPr lang="en-US" sz="1550" b="1" dirty="0">
+                <a:solidFill>
+                  <a:srgbClr val="1A1D23"/>
+                </a:solidFill>
+                <a:latin typeface="Calibri" pitchFamily="34" charset="0"/>
+                <a:ea typeface="Calibri" pitchFamily="34" charset="-122"/>
+                <a:cs typeface="Calibri" pitchFamily="34" charset="-120"/>
+              </a:rPr>
+              <a:t>Lo que estoy aprendiendo haciendo esto es exactamente lo que buscan las empresas de ingeniería — en Europa y donde sea.</a:t>
+            </a:r>
+            <a:endParaRPr lang="en-US" sz="1550" dirty="0"/>
+          </a:p>
+        </p:txBody>
+      </p:sp>
+      <p:sp>
+        <p:nvSpPr>
+          <p:cNvPr id="6" name="Shape 4"/>
+          <p:cNvSpPr/>
+          <p:nvPr/>
+        </p:nvSpPr>
+        <p:spPr>
+          <a:xfrm>
+            <a:off x="640080" y="2926080"/>
+            <a:ext cx="5257800" cy="1005840"/>
+          </a:xfrm>
+          <a:prstGeom prst="roundRect">
+            <a:avLst>
+              <a:gd name="adj" fmla="val 9091"/>
+            </a:avLst>
+          </a:prstGeom>
+          <a:solidFill>
+            <a:srgbClr val="FFFFFF"/>
+          </a:solidFill>
+          <a:ln/>
+          <a:effectLst>
+            <a:outerShdw sx="100000" sy="100000" kx="0" ky="0" algn="bl" rotWithShape="0" blurRad="127000" dist="25400" dir="5400000">
+              <a:srgbClr val="000000">
+                <a:alpha val="18000"/>
+              </a:srgbClr>
+            </a:outerShdw>
+          </a:effectLst>
+        </p:spPr>
+      </p:sp>
+      <p:sp>
+        <p:nvSpPr>
+          <p:cNvPr id="7" name="Shape 5"/>
+          <p:cNvSpPr/>
+          <p:nvPr/>
+        </p:nvSpPr>
+        <p:spPr>
+          <a:xfrm>
+            <a:off x="640080" y="2926080"/>
+            <a:ext cx="82296" cy="1005840"/>
+          </a:xfrm>
+          <a:prstGeom prst="rect">
+            <a:avLst/>
+          </a:prstGeom>
+          <a:solidFill>
+            <a:srgbClr val="2E6FB0"/>
+          </a:solidFill>
+          <a:ln/>
+        </p:spPr>
+      </p:sp>
+      <p:sp>
+        <p:nvSpPr>
+          <p:cNvPr id="8" name="Text 6"/>
+          <p:cNvSpPr/>
+          <p:nvPr/>
+        </p:nvSpPr>
+        <p:spPr>
+          <a:xfrm>
+            <a:off x="960120" y="3090672"/>
+            <a:ext cx="4846320" cy="365760"/>
+          </a:xfrm>
+          <a:prstGeom prst="rect">
+            <a:avLst/>
+          </a:prstGeom>
+          <a:noFill/>
+          <a:ln/>
+        </p:spPr>
+        <p:txBody>
+          <a:bodyPr wrap="square" lIns="0" tIns="0" rIns="0" bIns="0" rtlCol="0" anchor="ctr"/>
+          <a:lstStyle/>
+          <a:p>
+            <a:pPr indent="0" marL="0">
+              <a:buNone/>
+            </a:pPr>
+            <a:r>
+              <a:rPr lang="en-US" sz="1400" b="1" dirty="0">
+                <a:solidFill>
+                  <a:srgbClr val="1A1D23"/>
+                </a:solidFill>
+                <a:latin typeface="Cambria" pitchFamily="34" charset="0"/>
+                <a:ea typeface="Cambria" pitchFamily="34" charset="-122"/>
+                <a:cs typeface="Cambria" pitchFamily="34" charset="-120"/>
+              </a:rPr>
+              <a:t>Ingeniería inversa de sistemas</a:t>
+            </a:r>
+            <a:endParaRPr lang="en-US" sz="1400" dirty="0"/>
+          </a:p>
+        </p:txBody>
+      </p:sp>
+      <p:sp>
+        <p:nvSpPr>
+          <p:cNvPr id="9" name="Text 7"/>
+          <p:cNvSpPr/>
+          <p:nvPr/>
+        </p:nvSpPr>
+        <p:spPr>
+          <a:xfrm>
+            <a:off x="960120" y="3456432"/>
+            <a:ext cx="4846320" cy="411480"/>
+          </a:xfrm>
+          <a:prstGeom prst="rect">
+            <a:avLst/>
+          </a:prstGeom>
+          <a:noFill/>
+          <a:ln/>
+        </p:spPr>
+        <p:txBody>
+          <a:bodyPr wrap="square" lIns="0" tIns="0" rIns="0" bIns="0" rtlCol="0" anchor="ctr"/>
+          <a:lstStyle/>
+          <a:p>
+            <a:pPr indent="0" marL="0">
+              <a:buNone/>
+            </a:pPr>
+            <a:r>
+              <a:rPr lang="en-US" sz="1200" dirty="0">
+                <a:solidFill>
+                  <a:srgbClr val="5B6470"/>
+                </a:solidFill>
+                <a:latin typeface="Calibri" pitchFamily="34" charset="0"/>
+                <a:ea typeface="Calibri" pitchFamily="34" charset="-122"/>
+                <a:cs typeface="Calibri" pitchFamily="34" charset="-120"/>
+              </a:rPr>
+              <a:t>Leerle y hablarle al bus de una máquina cerrada.</a:t>
+            </a:r>
+            <a:endParaRPr lang="en-US" sz="1200" dirty="0"/>
+          </a:p>
+        </p:txBody>
+      </p:sp>
+      <p:sp>
+        <p:nvSpPr>
+          <p:cNvPr id="10" name="Shape 8"/>
+          <p:cNvSpPr/>
+          <p:nvPr/>
+        </p:nvSpPr>
+        <p:spPr>
+          <a:xfrm>
+            <a:off x="6263640" y="2926080"/>
+            <a:ext cx="5257800" cy="1005840"/>
+          </a:xfrm>
+          <a:prstGeom prst="roundRect">
+            <a:avLst>
+              <a:gd name="adj" fmla="val 9091"/>
+            </a:avLst>
+          </a:prstGeom>
+          <a:solidFill>
+            <a:srgbClr val="FFFFFF"/>
+          </a:solidFill>
+          <a:ln/>
+          <a:effectLst>
+            <a:outerShdw sx="100000" sy="100000" kx="0" ky="0" algn="bl" rotWithShape="0" blurRad="127000" dist="25400" dir="5400000">
+              <a:srgbClr val="000000">
+                <a:alpha val="18000"/>
+              </a:srgbClr>
+            </a:outerShdw>
+          </a:effectLst>
+        </p:spPr>
+      </p:sp>
+      <p:sp>
+        <p:nvSpPr>
+          <p:cNvPr id="11" name="Shape 9"/>
+          <p:cNvSpPr/>
+          <p:nvPr/>
+        </p:nvSpPr>
+        <p:spPr>
+          <a:xfrm>
+            <a:off x="6263640" y="2926080"/>
+            <a:ext cx="82296" cy="1005840"/>
+          </a:xfrm>
+          <a:prstGeom prst="rect">
+            <a:avLst/>
+          </a:prstGeom>
+          <a:solidFill>
+            <a:srgbClr val="2E6FB0"/>
+          </a:solidFill>
+          <a:ln/>
+        </p:spPr>
+      </p:sp>
+      <p:sp>
+        <p:nvSpPr>
+          <p:cNvPr id="12" name="Text 10"/>
+          <p:cNvSpPr/>
+          <p:nvPr/>
+        </p:nvSpPr>
+        <p:spPr>
+          <a:xfrm>
+            <a:off x="6583680" y="3090672"/>
+            <a:ext cx="4846320" cy="365760"/>
+          </a:xfrm>
+          <a:prstGeom prst="rect">
+            <a:avLst/>
+          </a:prstGeom>
+          <a:noFill/>
+          <a:ln/>
+        </p:spPr>
+        <p:txBody>
+          <a:bodyPr wrap="square" lIns="0" tIns="0" rIns="0" bIns="0" rtlCol="0" anchor="ctr"/>
+          <a:lstStyle/>
+          <a:p>
+            <a:pPr indent="0" marL="0">
+              <a:buNone/>
+            </a:pPr>
+            <a:r>
+              <a:rPr lang="en-US" sz="1400" b="1" dirty="0">
+                <a:solidFill>
+                  <a:srgbClr val="1A1D23"/>
+                </a:solidFill>
+                <a:latin typeface="Cambria" pitchFamily="34" charset="0"/>
+                <a:ea typeface="Cambria" pitchFamily="34" charset="-122"/>
+                <a:cs typeface="Cambria" pitchFamily="34" charset="-120"/>
+              </a:rPr>
+              <a:t>Sistemas embebidos y firmware</a:t>
+            </a:r>
+            <a:endParaRPr lang="en-US" sz="1400" dirty="0"/>
+          </a:p>
+        </p:txBody>
+      </p:sp>
+      <p:sp>
+        <p:nvSpPr>
+          <p:cNvPr id="13" name="Text 11"/>
+          <p:cNvSpPr/>
+          <p:nvPr/>
+        </p:nvSpPr>
+        <p:spPr>
+          <a:xfrm>
+            <a:off x="6583680" y="3456432"/>
+            <a:ext cx="4846320" cy="411480"/>
+          </a:xfrm>
+          <a:prstGeom prst="rect">
+            <a:avLst/>
+          </a:prstGeom>
+          <a:noFill/>
+          <a:ln/>
+        </p:spPr>
+        <p:txBody>
+          <a:bodyPr wrap="square" lIns="0" tIns="0" rIns="0" bIns="0" rtlCol="0" anchor="ctr"/>
+          <a:lstStyle/>
+          <a:p>
+            <a:pPr indent="0" marL="0">
+              <a:buNone/>
+            </a:pPr>
+            <a:r>
+              <a:rPr lang="en-US" sz="1200" dirty="0">
+                <a:solidFill>
+                  <a:srgbClr val="5B6470"/>
+                </a:solidFill>
+                <a:latin typeface="Calibri" pitchFamily="34" charset="0"/>
+                <a:ea typeface="Calibri" pitchFamily="34" charset="-122"/>
+                <a:cs typeface="Calibri" pitchFamily="34" charset="-120"/>
+              </a:rPr>
+              <a:t>Programar los microcontroladores que mandan.</a:t>
+            </a:r>
+            <a:endParaRPr lang="en-US" sz="1200" dirty="0"/>
+          </a:p>
+        </p:txBody>
+      </p:sp>
+      <p:sp>
+        <p:nvSpPr>
+          <p:cNvPr id="14" name="Shape 12"/>
+          <p:cNvSpPr/>
+          <p:nvPr/>
+        </p:nvSpPr>
+        <p:spPr>
+          <a:xfrm>
+            <a:off x="640080" y="4069080"/>
+            <a:ext cx="5257800" cy="1005840"/>
+          </a:xfrm>
+          <a:prstGeom prst="roundRect">
+            <a:avLst>
+              <a:gd name="adj" fmla="val 9091"/>
+            </a:avLst>
+          </a:prstGeom>
+          <a:solidFill>
+            <a:srgbClr val="FFFFFF"/>
+          </a:solidFill>
+          <a:ln/>
+          <a:effectLst>
+            <a:outerShdw sx="100000" sy="100000" kx="0" ky="0" algn="bl" rotWithShape="0" blurRad="127000" dist="25400" dir="5400000">
+              <a:srgbClr val="000000">
+                <a:alpha val="18000"/>
+              </a:srgbClr>
+            </a:outerShdw>
+          </a:effectLst>
+        </p:spPr>
+      </p:sp>
+      <p:sp>
+        <p:nvSpPr>
+          <p:cNvPr id="15" name="Shape 13"/>
+          <p:cNvSpPr/>
+          <p:nvPr/>
+        </p:nvSpPr>
+        <p:spPr>
+          <a:xfrm>
+            <a:off x="640080" y="4069080"/>
+            <a:ext cx="82296" cy="1005840"/>
+          </a:xfrm>
+          <a:prstGeom prst="rect">
+            <a:avLst/>
+          </a:prstGeom>
+          <a:solidFill>
+            <a:srgbClr val="2E6FB0"/>
+          </a:solidFill>
+          <a:ln/>
+        </p:spPr>
+      </p:sp>
+      <p:sp>
+        <p:nvSpPr>
+          <p:cNvPr id="16" name="Text 14"/>
+          <p:cNvSpPr/>
+          <p:nvPr/>
+        </p:nvSpPr>
+        <p:spPr>
+          <a:xfrm>
+            <a:off x="960120" y="4233672"/>
+            <a:ext cx="4846320" cy="365760"/>
+          </a:xfrm>
+          <a:prstGeom prst="rect">
+            <a:avLst/>
+          </a:prstGeom>
+          <a:noFill/>
+          <a:ln/>
+        </p:spPr>
+        <p:txBody>
+          <a:bodyPr wrap="square" lIns="0" tIns="0" rIns="0" bIns="0" rtlCol="0" anchor="ctr"/>
+          <a:lstStyle/>
+          <a:p>
+            <a:pPr indent="0" marL="0">
+              <a:buNone/>
+            </a:pPr>
+            <a:r>
+              <a:rPr lang="en-US" sz="1400" b="1" dirty="0">
+                <a:solidFill>
+                  <a:srgbClr val="1A1D23"/>
+                </a:solidFill>
+                <a:latin typeface="Cambria" pitchFamily="34" charset="0"/>
+                <a:ea typeface="Cambria" pitchFamily="34" charset="-122"/>
+                <a:cs typeface="Cambria" pitchFamily="34" charset="-120"/>
+              </a:rPr>
+              <a:t>Control y automatización</a:t>
+            </a:r>
+            <a:endParaRPr lang="en-US" sz="1400" dirty="0"/>
+          </a:p>
+        </p:txBody>
+      </p:sp>
+      <p:sp>
+        <p:nvSpPr>
+          <p:cNvPr id="17" name="Text 15"/>
+          <p:cNvSpPr/>
+          <p:nvPr/>
+        </p:nvSpPr>
+        <p:spPr>
+          <a:xfrm>
+            <a:off x="960120" y="4599432"/>
+            <a:ext cx="4846320" cy="411480"/>
+          </a:xfrm>
+          <a:prstGeom prst="rect">
+            <a:avLst/>
+          </a:prstGeom>
+          <a:noFill/>
+          <a:ln/>
+        </p:spPr>
+        <p:txBody>
+          <a:bodyPr wrap="square" lIns="0" tIns="0" rIns="0" bIns="0" rtlCol="0" anchor="ctr"/>
+          <a:lstStyle/>
+          <a:p>
+            <a:pPr indent="0" marL="0">
+              <a:buNone/>
+            </a:pPr>
+            <a:r>
+              <a:rPr lang="en-US" sz="1200" dirty="0">
+                <a:solidFill>
+                  <a:srgbClr val="5B6470"/>
+                </a:solidFill>
+                <a:latin typeface="Calibri" pitchFamily="34" charset="0"/>
+                <a:ea typeface="Calibri" pitchFamily="34" charset="-122"/>
+                <a:cs typeface="Calibri" pitchFamily="34" charset="-120"/>
+              </a:rPr>
+              <a:t>Manejar maquinaria pesada con seguridad.</a:t>
+            </a:r>
+            <a:endParaRPr lang="en-US" sz="1200" dirty="0"/>
+          </a:p>
+        </p:txBody>
+      </p:sp>
+      <p:sp>
+        <p:nvSpPr>
+          <p:cNvPr id="18" name="Shape 16"/>
+          <p:cNvSpPr/>
+          <p:nvPr/>
+        </p:nvSpPr>
+        <p:spPr>
+          <a:xfrm>
+            <a:off x="6263640" y="4069080"/>
+            <a:ext cx="5257800" cy="1005840"/>
+          </a:xfrm>
+          <a:prstGeom prst="roundRect">
+            <a:avLst>
+              <a:gd name="adj" fmla="val 9091"/>
+            </a:avLst>
+          </a:prstGeom>
+          <a:solidFill>
+            <a:srgbClr val="FFFFFF"/>
+          </a:solidFill>
+          <a:ln/>
+          <a:effectLst>
+            <a:outerShdw sx="100000" sy="100000" kx="0" ky="0" algn="bl" rotWithShape="0" blurRad="127000" dist="25400" dir="5400000">
+              <a:srgbClr val="000000">
+                <a:alpha val="18000"/>
+              </a:srgbClr>
+            </a:outerShdw>
+          </a:effectLst>
+        </p:spPr>
+      </p:sp>
+      <p:sp>
+        <p:nvSpPr>
+          <p:cNvPr id="19" name="Shape 17"/>
+          <p:cNvSpPr/>
+          <p:nvPr/>
+        </p:nvSpPr>
+        <p:spPr>
+          <a:xfrm>
+            <a:off x="6263640" y="4069080"/>
+            <a:ext cx="82296" cy="1005840"/>
+          </a:xfrm>
+          <a:prstGeom prst="rect">
+            <a:avLst/>
+          </a:prstGeom>
+          <a:solidFill>
+            <a:srgbClr val="2E6FB0"/>
+          </a:solidFill>
+          <a:ln/>
+        </p:spPr>
+      </p:sp>
+      <p:sp>
+        <p:nvSpPr>
+          <p:cNvPr id="20" name="Text 18"/>
+          <p:cNvSpPr/>
+          <p:nvPr/>
+        </p:nvSpPr>
+        <p:spPr>
+          <a:xfrm>
+            <a:off x="6583680" y="4233672"/>
+            <a:ext cx="4846320" cy="365760"/>
+          </a:xfrm>
+          <a:prstGeom prst="rect">
+            <a:avLst/>
+          </a:prstGeom>
+          <a:noFill/>
+          <a:ln/>
+        </p:spPr>
+        <p:txBody>
+          <a:bodyPr wrap="square" lIns="0" tIns="0" rIns="0" bIns="0" rtlCol="0" anchor="ctr"/>
+          <a:lstStyle/>
+          <a:p>
+            <a:pPr indent="0" marL="0">
+              <a:buNone/>
+            </a:pPr>
+            <a:r>
+              <a:rPr lang="en-US" sz="1400" b="1" dirty="0">
+                <a:solidFill>
+                  <a:srgbClr val="1A1D23"/>
+                </a:solidFill>
+                <a:latin typeface="Cambria" pitchFamily="34" charset="0"/>
+                <a:ea typeface="Cambria" pitchFamily="34" charset="-122"/>
+                <a:cs typeface="Cambria" pitchFamily="34" charset="-120"/>
+              </a:rPr>
+              <a:t>Robótica autónoma</a:t>
+            </a:r>
+            <a:endParaRPr lang="en-US" sz="1400" dirty="0"/>
+          </a:p>
+        </p:txBody>
+      </p:sp>
+      <p:sp>
+        <p:nvSpPr>
+          <p:cNvPr id="21" name="Text 19"/>
+          <p:cNvSpPr/>
+          <p:nvPr/>
+        </p:nvSpPr>
+        <p:spPr>
+          <a:xfrm>
+            <a:off x="6583680" y="4599432"/>
+            <a:ext cx="4846320" cy="411480"/>
+          </a:xfrm>
+          <a:prstGeom prst="rect">
+            <a:avLst/>
+          </a:prstGeom>
+          <a:noFill/>
+          <a:ln/>
+        </p:spPr>
+        <p:txBody>
+          <a:bodyPr wrap="square" lIns="0" tIns="0" rIns="0" bIns="0" rtlCol="0" anchor="ctr"/>
+          <a:lstStyle/>
+          <a:p>
+            <a:pPr indent="0" marL="0">
+              <a:buNone/>
+            </a:pPr>
+            <a:r>
+              <a:rPr lang="en-US" sz="1200" dirty="0">
+                <a:solidFill>
+                  <a:srgbClr val="5B6470"/>
+                </a:solidFill>
+                <a:latin typeface="Calibri" pitchFamily="34" charset="0"/>
+                <a:ea typeface="Calibri" pitchFamily="34" charset="-122"/>
+                <a:cs typeface="Calibri" pitchFamily="34" charset="-120"/>
+              </a:rPr>
+              <a:t>Sensores, cámaras y ubicación en el espacio.</a:t>
+            </a:r>
+            <a:endParaRPr lang="en-US" sz="1200" dirty="0"/>
+          </a:p>
+        </p:txBody>
+      </p:sp>
+      <p:sp>
+        <p:nvSpPr>
+          <p:cNvPr id="22" name="Text 20"/>
+          <p:cNvSpPr/>
+          <p:nvPr/>
+        </p:nvSpPr>
+        <p:spPr>
+          <a:xfrm>
+            <a:off x="640080" y="5394960"/>
+            <a:ext cx="10881360" cy="457200"/>
+          </a:xfrm>
+          <a:prstGeom prst="rect">
+            <a:avLst/>
+          </a:prstGeom>
+          <a:noFill/>
+          <a:ln/>
+        </p:spPr>
+        <p:txBody>
+          <a:bodyPr wrap="square" lIns="0" tIns="0" rIns="0" bIns="0" rtlCol="0" anchor="ctr"/>
+          <a:lstStyle/>
+          <a:p>
+            <a:pPr indent="0" marL="0">
+              <a:buNone/>
+            </a:pPr>
+            <a:r>
+              <a:rPr lang="en-US" sz="1300" i="1" dirty="0">
+                <a:solidFill>
+                  <a:srgbClr val="5B6470"/>
+                </a:solidFill>
+                <a:latin typeface="Calibri" pitchFamily="34" charset="0"/>
+                <a:ea typeface="Calibri" pitchFamily="34" charset="-122"/>
+                <a:cs typeface="Calibri" pitchFamily="34" charset="-120"/>
+              </a:rPr>
+              <a:t>Pocos ingenieros recién salidos las tienen — y menos aún las han hecho con sus manos en una máquina real.</a:t>
+            </a:r>
+            <a:endParaRPr lang="en-US" sz="1300" dirty="0"/>
+          </a:p>
+        </p:txBody>
+      </p:sp>
+    </p:spTree>
+  </p:cSld>
+  <p:clrMapOvr>
+    <a:masterClrMapping/>
+  </p:clrMapOvr>
+</p:sld>
+</file>
+
+<file path=ppt/slides/slide8.xml><?xml version="1.0" encoding="utf-8"?>
+<p:sld xmlns:a="http://schemas.openxmlformats.org/drawingml/2006/main" xmlns:r="http://schemas.openxmlformats.org/officeDocument/2006/relationships" xmlns:p="http://schemas.openxmlformats.org/presentationml/2006/main">
+  <p:cSld name="Slide 8">
+    <p:bg>
+      <p:bgPr>
+        <a:solidFill>
           <a:srgbClr val="14171C"/>
         </a:solidFill>
       </p:bgPr>
@@ -4060,34 +5247,14 @@
       </p:grpSpPr>
       <p:sp>
         <p:nvSpPr>
-          <p:cNvPr id="2" name="Shape 0"/>
-          <p:cNvSpPr/>
-          <p:nvPr/>
-        </p:nvSpPr>
-        <p:spPr>
-          <a:xfrm>
-            <a:off x="914400" y="2651760"/>
-            <a:ext cx="1463040" cy="45720"/>
-          </a:xfrm>
-          <a:prstGeom prst="rect">
-            <a:avLst/>
-          </a:prstGeom>
-          <a:solidFill>
-            <a:srgbClr val="E0A82E"/>
-          </a:solidFill>
-          <a:ln/>
-        </p:spPr>
-      </p:sp>
-      <p:sp>
-        <p:nvSpPr>
-          <p:cNvPr id="3" name="Text 1"/>
-          <p:cNvSpPr/>
-          <p:nvPr/>
-        </p:nvSpPr>
-        <p:spPr>
-          <a:xfrm>
-            <a:off x="868680" y="1737360"/>
-            <a:ext cx="10058400" cy="1463040"/>
+          <p:cNvPr id="2" name="Text 0"/>
+          <p:cNvSpPr/>
+          <p:nvPr/>
+        </p:nvSpPr>
+        <p:spPr>
+          <a:xfrm>
+            <a:off x="640080" y="457200"/>
+            <a:ext cx="10881360" cy="822960"/>
           </a:xfrm>
           <a:prstGeom prst="rect">
             <a:avLst/>
@@ -4100,13 +5267,10 @@
           <a:lstStyle/>
           <a:p>
             <a:pPr indent="0" marL="0">
-              <a:lnSpc>
-                <a:spcPts val="4400"/>
-              </a:lnSpc>
-              <a:buNone/>
-            </a:pPr>
-            <a:r>
-              <a:rPr lang="en-US" sz="3600" b="1" dirty="0">
+              <a:buNone/>
+            </a:pPr>
+            <a:r>
+              <a:rPr lang="en-US" sz="3200" b="1" dirty="0">
                 <a:solidFill>
                   <a:srgbClr val="ECEBE6"/>
                 </a:solidFill>
@@ -4114,19 +5278,126 @@
                 <a:ea typeface="Cambria" pitchFamily="34" charset="-122"/>
                 <a:cs typeface="Cambria" pitchFamily="34" charset="-120"/>
               </a:rPr>
-              <a:t>Esto es lo que estoy</a:t>
-            </a:r>
-            <a:endParaRPr lang="en-US" sz="3600" dirty="0"/>
-          </a:p>
-          <a:p>
-            <a:pPr indent="0" marL="0">
-              <a:lnSpc>
-                <a:spcPts val="4400"/>
-              </a:lnSpc>
-              <a:buNone/>
-            </a:pPr>
-            <a:r>
-              <a:rPr lang="en-US" sz="3600" b="1" dirty="0">
+              <a:t>El plan tiene red</a:t>
+            </a:r>
+            <a:endParaRPr lang="en-US" sz="3200" dirty="0"/>
+          </a:p>
+        </p:txBody>
+      </p:sp>
+      <p:sp>
+        <p:nvSpPr>
+          <p:cNvPr id="3" name="Text 1"/>
+          <p:cNvSpPr/>
+          <p:nvPr/>
+        </p:nvSpPr>
+        <p:spPr>
+          <a:xfrm>
+            <a:off x="640080" y="1234440"/>
+            <a:ext cx="10881360" cy="411480"/>
+          </a:xfrm>
+          <a:prstGeom prst="rect">
+            <a:avLst/>
+          </a:prstGeom>
+          <a:noFill/>
+          <a:ln/>
+        </p:spPr>
+        <p:txBody>
+          <a:bodyPr wrap="square" lIns="0" tIns="0" rIns="0" bIns="0" rtlCol="0" anchor="ctr"/>
+          <a:lstStyle/>
+          <a:p>
+            <a:pPr indent="0" marL="0">
+              <a:buNone/>
+            </a:pPr>
+            <a:r>
+              <a:rPr lang="en-US" sz="1500" dirty="0">
+                <a:solidFill>
+                  <a:srgbClr val="8B949E"/>
+                </a:solidFill>
+                <a:latin typeface="Calibri" pitchFamily="34" charset="0"/>
+                <a:ea typeface="Calibri" pitchFamily="34" charset="-122"/>
+                <a:cs typeface="Calibri" pitchFamily="34" charset="-120"/>
+              </a:rPr>
+              <a:t>Pase lo que pase con el proyecto, esta experiencia ya me abrió una puerta</a:t>
+            </a:r>
+            <a:endParaRPr lang="en-US" sz="1500" dirty="0"/>
+          </a:p>
+        </p:txBody>
+      </p:sp>
+      <p:sp>
+        <p:nvSpPr>
+          <p:cNvPr id="4" name="Shape 2"/>
+          <p:cNvSpPr/>
+          <p:nvPr/>
+        </p:nvSpPr>
+        <p:spPr>
+          <a:xfrm>
+            <a:off x="640080" y="2011680"/>
+            <a:ext cx="3474720" cy="2651760"/>
+          </a:xfrm>
+          <a:prstGeom prst="roundRect">
+            <a:avLst>
+              <a:gd name="adj" fmla="val 3448"/>
+            </a:avLst>
+          </a:prstGeom>
+          <a:solidFill>
+            <a:srgbClr val="20242B"/>
+          </a:solidFill>
+          <a:ln/>
+          <a:effectLst>
+            <a:outerShdw sx="100000" sy="100000" kx="0" ky="0" algn="bl" rotWithShape="0" blurRad="127000" dist="25400" dir="5400000">
+              <a:srgbClr val="000000">
+                <a:alpha val="18000"/>
+              </a:srgbClr>
+            </a:outerShdw>
+          </a:effectLst>
+        </p:spPr>
+      </p:sp>
+      <p:sp>
+        <p:nvSpPr>
+          <p:cNvPr id="5" name="Shape 3"/>
+          <p:cNvSpPr/>
+          <p:nvPr/>
+        </p:nvSpPr>
+        <p:spPr>
+          <a:xfrm>
+            <a:off x="640080" y="2011680"/>
+            <a:ext cx="3474720" cy="109728"/>
+          </a:xfrm>
+          <a:prstGeom prst="rect">
+            <a:avLst/>
+          </a:prstGeom>
+          <a:solidFill>
+            <a:srgbClr val="2FA866"/>
+          </a:solidFill>
+          <a:ln/>
+        </p:spPr>
+      </p:sp>
+      <p:sp>
+        <p:nvSpPr>
+          <p:cNvPr id="6" name="Text 4"/>
+          <p:cNvSpPr/>
+          <p:nvPr/>
+        </p:nvSpPr>
+        <p:spPr>
+          <a:xfrm>
+            <a:off x="960120" y="2377440"/>
+            <a:ext cx="2926080" cy="457200"/>
+          </a:xfrm>
+          <a:prstGeom prst="rect">
+            <a:avLst/>
+          </a:prstGeom>
+          <a:noFill/>
+          <a:ln/>
+        </p:spPr>
+        <p:txBody>
+          <a:bodyPr wrap="square" lIns="0" tIns="0" rIns="0" bIns="0" rtlCol="0" anchor="ctr"/>
+          <a:lstStyle/>
+          <a:p>
+            <a:pPr indent="0" marL="0">
+              <a:buNone/>
+            </a:pPr>
+            <a:r>
+              <a:rPr lang="en-US" sz="1800" b="1" dirty="0">
                 <a:solidFill>
                   <a:srgbClr val="ECEBE6"/>
                 </a:solidFill>
@@ -4134,11 +5405,481 @@
                 <a:ea typeface="Cambria" pitchFamily="34" charset="-122"/>
                 <a:cs typeface="Cambria" pitchFamily="34" charset="-120"/>
               </a:rPr>
-              <a:t>construyendo.</a:t>
-            </a:r>
-            <a:endParaRPr lang="en-US" sz="3600" dirty="0"/>
-          </a:p>
-        </p:txBody>
+              <a:t>Si sale</a:t>
+            </a:r>
+            <a:endParaRPr lang="en-US" sz="1800" dirty="0"/>
+          </a:p>
+        </p:txBody>
+      </p:sp>
+      <p:sp>
+        <p:nvSpPr>
+          <p:cNvPr id="7" name="Text 5"/>
+          <p:cNvSpPr/>
+          <p:nvPr/>
+        </p:nvSpPr>
+        <p:spPr>
+          <a:xfrm>
+            <a:off x="960120" y="3017520"/>
+            <a:ext cx="2880360" cy="1463040"/>
+          </a:xfrm>
+          <a:prstGeom prst="rect">
+            <a:avLst/>
+          </a:prstGeom>
+          <a:noFill/>
+          <a:ln/>
+        </p:spPr>
+        <p:txBody>
+          <a:bodyPr wrap="square" lIns="0" tIns="0" rIns="0" bIns="0" rtlCol="0" anchor="t"/>
+          <a:lstStyle/>
+          <a:p>
+            <a:pPr indent="0" marL="0">
+              <a:lnSpc>
+                <a:spcPts val="2000"/>
+              </a:lnSpc>
+              <a:buNone/>
+            </a:pPr>
+            <a:r>
+              <a:rPr lang="en-US" sz="1300" dirty="0">
+                <a:solidFill>
+                  <a:srgbClr val="8B949E"/>
+                </a:solidFill>
+                <a:latin typeface="Calibri" pitchFamily="34" charset="0"/>
+                <a:ea typeface="Calibri" pitchFamily="34" charset="-122"/>
+                <a:cs typeface="Calibri" pitchFamily="34" charset="-120"/>
+              </a:rPr>
+              <a:t>Levanto mi empresa, vendo el primer TaTa, consigo el Aula — y sigo construyendo esto acá.</a:t>
+            </a:r>
+            <a:endParaRPr lang="en-US" sz="1300" dirty="0"/>
+          </a:p>
+        </p:txBody>
+      </p:sp>
+      <p:sp>
+        <p:nvSpPr>
+          <p:cNvPr id="8" name="Shape 6"/>
+          <p:cNvSpPr/>
+          <p:nvPr/>
+        </p:nvSpPr>
+        <p:spPr>
+          <a:xfrm>
+            <a:off x="4343400" y="2011680"/>
+            <a:ext cx="3474720" cy="2651760"/>
+          </a:xfrm>
+          <a:prstGeom prst="roundRect">
+            <a:avLst>
+              <a:gd name="adj" fmla="val 3448"/>
+            </a:avLst>
+          </a:prstGeom>
+          <a:solidFill>
+            <a:srgbClr val="20242B"/>
+          </a:solidFill>
+          <a:ln/>
+          <a:effectLst>
+            <a:outerShdw sx="100000" sy="100000" kx="0" ky="0" algn="bl" rotWithShape="0" blurRad="127000" dist="25400" dir="5400000">
+              <a:srgbClr val="000000">
+                <a:alpha val="18000"/>
+              </a:srgbClr>
+            </a:outerShdw>
+          </a:effectLst>
+        </p:spPr>
+      </p:sp>
+      <p:sp>
+        <p:nvSpPr>
+          <p:cNvPr id="9" name="Shape 7"/>
+          <p:cNvSpPr/>
+          <p:nvPr/>
+        </p:nvSpPr>
+        <p:spPr>
+          <a:xfrm>
+            <a:off x="4343400" y="2011680"/>
+            <a:ext cx="3474720" cy="109728"/>
+          </a:xfrm>
+          <a:prstGeom prst="rect">
+            <a:avLst/>
+          </a:prstGeom>
+          <a:solidFill>
+            <a:srgbClr val="E0A82E"/>
+          </a:solidFill>
+          <a:ln/>
+        </p:spPr>
+      </p:sp>
+      <p:sp>
+        <p:nvSpPr>
+          <p:cNvPr id="10" name="Text 8"/>
+          <p:cNvSpPr/>
+          <p:nvPr/>
+        </p:nvSpPr>
+        <p:spPr>
+          <a:xfrm>
+            <a:off x="4663440" y="2377440"/>
+            <a:ext cx="2926080" cy="457200"/>
+          </a:xfrm>
+          <a:prstGeom prst="rect">
+            <a:avLst/>
+          </a:prstGeom>
+          <a:noFill/>
+          <a:ln/>
+        </p:spPr>
+        <p:txBody>
+          <a:bodyPr wrap="square" lIns="0" tIns="0" rIns="0" bIns="0" rtlCol="0" anchor="ctr"/>
+          <a:lstStyle/>
+          <a:p>
+            <a:pPr indent="0" marL="0">
+              <a:buNone/>
+            </a:pPr>
+            <a:r>
+              <a:rPr lang="en-US" sz="1800" b="1" dirty="0">
+                <a:solidFill>
+                  <a:srgbClr val="ECEBE6"/>
+                </a:solidFill>
+                <a:latin typeface="Cambria" pitchFamily="34" charset="0"/>
+                <a:ea typeface="Cambria" pitchFamily="34" charset="-122"/>
+                <a:cs typeface="Cambria" pitchFamily="34" charset="-120"/>
+              </a:rPr>
+              <a:t>Si no sale</a:t>
+            </a:r>
+            <a:endParaRPr lang="en-US" sz="1800" dirty="0"/>
+          </a:p>
+        </p:txBody>
+      </p:sp>
+      <p:sp>
+        <p:nvSpPr>
+          <p:cNvPr id="11" name="Text 9"/>
+          <p:cNvSpPr/>
+          <p:nvPr/>
+        </p:nvSpPr>
+        <p:spPr>
+          <a:xfrm>
+            <a:off x="4663440" y="3017520"/>
+            <a:ext cx="2880360" cy="1463040"/>
+          </a:xfrm>
+          <a:prstGeom prst="rect">
+            <a:avLst/>
+          </a:prstGeom>
+          <a:noFill/>
+          <a:ln/>
+        </p:spPr>
+        <p:txBody>
+          <a:bodyPr wrap="square" lIns="0" tIns="0" rIns="0" bIns="0" rtlCol="0" anchor="t"/>
+          <a:lstStyle/>
+          <a:p>
+            <a:pPr indent="0" marL="0">
+              <a:lnSpc>
+                <a:spcPts val="2000"/>
+              </a:lnSpc>
+              <a:buNone/>
+            </a:pPr>
+            <a:r>
+              <a:rPr lang="en-US" sz="1300" dirty="0">
+                <a:solidFill>
+                  <a:srgbClr val="8B949E"/>
+                </a:solidFill>
+                <a:latin typeface="Calibri" pitchFamily="34" charset="0"/>
+                <a:ea typeface="Calibri" pitchFamily="34" charset="-122"/>
+                <a:cs typeface="Calibri" pitchFamily="34" charset="-120"/>
+              </a:rPr>
+              <a:t>Esta misma experiencia me abre un trabajo de ingeniería en una empresa en Europa.</a:t>
+            </a:r>
+            <a:endParaRPr lang="en-US" sz="1300" dirty="0"/>
+          </a:p>
+        </p:txBody>
+      </p:sp>
+      <p:sp>
+        <p:nvSpPr>
+          <p:cNvPr id="12" name="Shape 10"/>
+          <p:cNvSpPr/>
+          <p:nvPr/>
+        </p:nvSpPr>
+        <p:spPr>
+          <a:xfrm>
+            <a:off x="8046720" y="2011680"/>
+            <a:ext cx="3474720" cy="2651760"/>
+          </a:xfrm>
+          <a:prstGeom prst="roundRect">
+            <a:avLst>
+              <a:gd name="adj" fmla="val 3448"/>
+            </a:avLst>
+          </a:prstGeom>
+          <a:solidFill>
+            <a:srgbClr val="20242B"/>
+          </a:solidFill>
+          <a:ln/>
+          <a:effectLst>
+            <a:outerShdw sx="100000" sy="100000" kx="0" ky="0" algn="bl" rotWithShape="0" blurRad="127000" dist="25400" dir="5400000">
+              <a:srgbClr val="000000">
+                <a:alpha val="18000"/>
+              </a:srgbClr>
+            </a:outerShdw>
+          </a:effectLst>
+        </p:spPr>
+      </p:sp>
+      <p:sp>
+        <p:nvSpPr>
+          <p:cNvPr id="13" name="Shape 11"/>
+          <p:cNvSpPr/>
+          <p:nvPr/>
+        </p:nvSpPr>
+        <p:spPr>
+          <a:xfrm>
+            <a:off x="8046720" y="2011680"/>
+            <a:ext cx="3474720" cy="109728"/>
+          </a:xfrm>
+          <a:prstGeom prst="rect">
+            <a:avLst/>
+          </a:prstGeom>
+          <a:solidFill>
+            <a:srgbClr val="2E6FB0"/>
+          </a:solidFill>
+          <a:ln/>
+        </p:spPr>
+      </p:sp>
+      <p:sp>
+        <p:nvSpPr>
+          <p:cNvPr id="14" name="Text 12"/>
+          <p:cNvSpPr/>
+          <p:nvPr/>
+        </p:nvSpPr>
+        <p:spPr>
+          <a:xfrm>
+            <a:off x="8366760" y="2377440"/>
+            <a:ext cx="2926080" cy="457200"/>
+          </a:xfrm>
+          <a:prstGeom prst="rect">
+            <a:avLst/>
+          </a:prstGeom>
+          <a:noFill/>
+          <a:ln/>
+        </p:spPr>
+        <p:txBody>
+          <a:bodyPr wrap="square" lIns="0" tIns="0" rIns="0" bIns="0" rtlCol="0" anchor="ctr"/>
+          <a:lstStyle/>
+          <a:p>
+            <a:pPr indent="0" marL="0">
+              <a:buNone/>
+            </a:pPr>
+            <a:r>
+              <a:rPr lang="en-US" sz="1800" b="1" dirty="0">
+                <a:solidFill>
+                  <a:srgbClr val="ECEBE6"/>
+                </a:solidFill>
+                <a:latin typeface="Cambria" pitchFamily="34" charset="0"/>
+                <a:ea typeface="Cambria" pitchFamily="34" charset="-122"/>
+                <a:cs typeface="Cambria" pitchFamily="34" charset="-120"/>
+              </a:rPr>
+              <a:t>De cualquier forma</a:t>
+            </a:r>
+            <a:endParaRPr lang="en-US" sz="1800" dirty="0"/>
+          </a:p>
+        </p:txBody>
+      </p:sp>
+      <p:sp>
+        <p:nvSpPr>
+          <p:cNvPr id="15" name="Text 13"/>
+          <p:cNvSpPr/>
+          <p:nvPr/>
+        </p:nvSpPr>
+        <p:spPr>
+          <a:xfrm>
+            <a:off x="8366760" y="3017520"/>
+            <a:ext cx="2880360" cy="1463040"/>
+          </a:xfrm>
+          <a:prstGeom prst="rect">
+            <a:avLst/>
+          </a:prstGeom>
+          <a:noFill/>
+          <a:ln/>
+        </p:spPr>
+        <p:txBody>
+          <a:bodyPr wrap="square" lIns="0" tIns="0" rIns="0" bIns="0" rtlCol="0" anchor="t"/>
+          <a:lstStyle/>
+          <a:p>
+            <a:pPr indent="0" marL="0">
+              <a:lnSpc>
+                <a:spcPts val="2000"/>
+              </a:lnSpc>
+              <a:buNone/>
+            </a:pPr>
+            <a:r>
+              <a:rPr lang="en-US" sz="1300" dirty="0">
+                <a:solidFill>
+                  <a:srgbClr val="8B949E"/>
+                </a:solidFill>
+                <a:latin typeface="Calibri" pitchFamily="34" charset="0"/>
+                <a:ea typeface="Calibri" pitchFamily="34" charset="-122"/>
+                <a:cs typeface="Calibri" pitchFamily="34" charset="-120"/>
+              </a:rPr>
+              <a:t>No es una apuesta de todo o nada. Gano experiencia que vale tenga o no éxito el proyecto.</a:t>
+            </a:r>
+            <a:endParaRPr lang="en-US" sz="1300" dirty="0"/>
+          </a:p>
+        </p:txBody>
+      </p:sp>
+      <p:sp>
+        <p:nvSpPr>
+          <p:cNvPr id="16" name="Shape 14"/>
+          <p:cNvSpPr/>
+          <p:nvPr/>
+        </p:nvSpPr>
+        <p:spPr>
+          <a:xfrm>
+            <a:off x="640080" y="4983480"/>
+            <a:ext cx="10881360" cy="914400"/>
+          </a:xfrm>
+          <a:prstGeom prst="roundRect">
+            <a:avLst>
+              <a:gd name="adj" fmla="val 10000"/>
+            </a:avLst>
+          </a:prstGeom>
+          <a:solidFill>
+            <a:srgbClr val="20242B"/>
+          </a:solidFill>
+          <a:ln/>
+          <a:effectLst>
+            <a:outerShdw sx="100000" sy="100000" kx="0" ky="0" algn="bl" rotWithShape="0" blurRad="127000" dist="25400" dir="5400000">
+              <a:srgbClr val="000000">
+                <a:alpha val="18000"/>
+              </a:srgbClr>
+            </a:outerShdw>
+          </a:effectLst>
+        </p:spPr>
+      </p:sp>
+      <p:sp>
+        <p:nvSpPr>
+          <p:cNvPr id="17" name="Text 15"/>
+          <p:cNvSpPr/>
+          <p:nvPr/>
+        </p:nvSpPr>
+        <p:spPr>
+          <a:xfrm>
+            <a:off x="1005840" y="4983480"/>
+            <a:ext cx="10149840" cy="914400"/>
+          </a:xfrm>
+          <a:prstGeom prst="rect">
+            <a:avLst/>
+          </a:prstGeom>
+          <a:noFill/>
+          <a:ln/>
+        </p:spPr>
+        <p:txBody>
+          <a:bodyPr wrap="square" lIns="0" tIns="0" rIns="0" bIns="0" rtlCol="0" anchor="ctr"/>
+          <a:lstStyle/>
+          <a:p>
+            <a:pPr indent="0" marL="0">
+              <a:buNone/>
+            </a:pPr>
+            <a:r>
+              <a:rPr lang="en-US" sz="1600" b="1" dirty="0">
+                <a:solidFill>
+                  <a:srgbClr val="E0A82E"/>
+                </a:solidFill>
+                <a:latin typeface="Calibri" pitchFamily="34" charset="0"/>
+                <a:ea typeface="Calibri" pitchFamily="34" charset="-122"/>
+                <a:cs typeface="Calibri" pitchFamily="34" charset="-120"/>
+              </a:rPr>
+              <a:t>Esto no es alejarme de conseguir trabajo. Es cómo consigo uno — y uno que pocos pueden hacer.</a:t>
+            </a:r>
+            <a:endParaRPr lang="en-US" sz="1600" dirty="0"/>
+          </a:p>
+        </p:txBody>
+      </p:sp>
+    </p:spTree>
+  </p:cSld>
+  <p:clrMapOvr>
+    <a:masterClrMapping/>
+  </p:clrMapOvr>
+</p:sld>
+</file>
+
+<file path=ppt/slides/slide9.xml><?xml version="1.0" encoding="utf-8"?>
+<p:sld xmlns:a="http://schemas.openxmlformats.org/drawingml/2006/main" xmlns:r="http://schemas.openxmlformats.org/officeDocument/2006/relationships" xmlns:p="http://schemas.openxmlformats.org/presentationml/2006/main">
+  <p:cSld name="Slide 9">
+    <p:bg>
+      <p:bgPr>
+        <a:solidFill>
+          <a:srgbClr val="F7F6F2"/>
+        </a:solidFill>
+      </p:bgPr>
+    </p:bg>
+    <p:spTree>
+      <p:nvGrpSpPr>
+        <p:cNvPr id="1" name=""/>
+        <p:cNvGrpSpPr/>
+        <p:nvPr/>
+      </p:nvGrpSpPr>
+      <p:grpSpPr>
+        <a:xfrm>
+          <a:off x="0" y="0"/>
+          <a:ext cx="0" cy="0"/>
+          <a:chOff x="0" y="0"/>
+          <a:chExt cx="0" cy="0"/>
+        </a:xfrm>
+      </p:grpSpPr>
+      <p:sp>
+        <p:nvSpPr>
+          <p:cNvPr id="2" name="Text 0"/>
+          <p:cNvSpPr/>
+          <p:nvPr/>
+        </p:nvSpPr>
+        <p:spPr>
+          <a:xfrm>
+            <a:off x="640080" y="457200"/>
+            <a:ext cx="10881360" cy="822960"/>
+          </a:xfrm>
+          <a:prstGeom prst="rect">
+            <a:avLst/>
+          </a:prstGeom>
+          <a:noFill/>
+          <a:ln/>
+        </p:spPr>
+        <p:txBody>
+          <a:bodyPr wrap="square" lIns="0" tIns="0" rIns="0" bIns="0" rtlCol="0" anchor="ctr"/>
+          <a:lstStyle/>
+          <a:p>
+            <a:pPr indent="0" marL="0">
+              <a:buNone/>
+            </a:pPr>
+            <a:r>
+              <a:rPr lang="en-US" sz="3200" b="1" dirty="0">
+                <a:solidFill>
+                  <a:srgbClr val="1A1D23"/>
+                </a:solidFill>
+                <a:latin typeface="Cambria" pitchFamily="34" charset="0"/>
+                <a:ea typeface="Cambria" pitchFamily="34" charset="-122"/>
+                <a:cs typeface="Cambria" pitchFamily="34" charset="-120"/>
+              </a:rPr>
+              <a:t>Por qué a veces no nos entendemos</a:t>
+            </a:r>
+            <a:endParaRPr lang="en-US" sz="3200" dirty="0"/>
+          </a:p>
+        </p:txBody>
+      </p:sp>
+      <p:sp>
+        <p:nvSpPr>
+          <p:cNvPr id="3" name="Shape 1"/>
+          <p:cNvSpPr/>
+          <p:nvPr/>
+        </p:nvSpPr>
+        <p:spPr>
+          <a:xfrm>
+            <a:off x="640080" y="1737360"/>
+            <a:ext cx="10881360" cy="1097280"/>
+          </a:xfrm>
+          <a:prstGeom prst="roundRect">
+            <a:avLst>
+              <a:gd name="adj" fmla="val 8333"/>
+            </a:avLst>
+          </a:prstGeom>
+          <a:solidFill>
+            <a:srgbClr val="FFFFFF"/>
+          </a:solidFill>
+          <a:ln/>
+          <a:effectLst>
+            <a:outerShdw sx="100000" sy="100000" kx="0" ky="0" algn="bl" rotWithShape="0" blurRad="127000" dist="25400" dir="5400000">
+              <a:srgbClr val="000000">
+                <a:alpha val="18000"/>
+              </a:srgbClr>
+            </a:outerShdw>
+          </a:effectLst>
+        </p:spPr>
       </p:sp>
       <p:sp>
         <p:nvSpPr>
@@ -4148,8 +5889,8 @@
         </p:nvSpPr>
         <p:spPr>
           <a:xfrm>
-            <a:off x="914400" y="3566160"/>
-            <a:ext cx="9601200" cy="1097280"/>
+            <a:off x="1005840" y="1737360"/>
+            <a:ext cx="10149840" cy="1097280"/>
           </a:xfrm>
           <a:prstGeom prst="rect">
             <a:avLst/>
@@ -4168,17 +5909,159 @@
               <a:buNone/>
             </a:pPr>
             <a:r>
-              <a:rPr lang="en-US" sz="1600" dirty="0">
-                <a:solidFill>
-                  <a:srgbClr val="8B949E"/>
+              <a:rPr lang="en-US" sz="1600" b="1" dirty="0">
+                <a:solidFill>
+                  <a:srgbClr val="1A1D23"/>
                 </a:solidFill>
                 <a:latin typeface="Calibri" pitchFamily="34" charset="0"/>
                 <a:ea typeface="Calibri" pitchFamily="34" charset="-122"/>
                 <a:cs typeface="Calibri" pitchFamily="34" charset="-120"/>
               </a:rPr>
-              <a:t>Toma tiempo porque nadie lo ha hecho antes en estos equipos. Pero ya funciona en mi mesa, y la empresa está detrás.</a:t>
+              <a:t>Que no entiendan lo que hago no significa que no tenga sentido. Significa que hablamos lenguajes distintos — y este todavía no lo compartimos.</a:t>
             </a:r>
             <a:endParaRPr lang="en-US" sz="1600" dirty="0"/>
+          </a:p>
+        </p:txBody>
+      </p:sp>
+      <p:sp>
+        <p:nvSpPr>
+          <p:cNvPr id="5" name="Shape 3"/>
+          <p:cNvSpPr/>
+          <p:nvPr/>
+        </p:nvSpPr>
+        <p:spPr>
+          <a:xfrm>
+            <a:off x="640080" y="3063240"/>
+            <a:ext cx="10881360" cy="1188720"/>
+          </a:xfrm>
+          <a:prstGeom prst="roundRect">
+            <a:avLst>
+              <a:gd name="adj" fmla="val 7692"/>
+            </a:avLst>
+          </a:prstGeom>
+          <a:solidFill>
+            <a:srgbClr val="FFFFFF"/>
+          </a:solidFill>
+          <a:ln/>
+          <a:effectLst>
+            <a:outerShdw sx="100000" sy="100000" kx="0" ky="0" algn="bl" rotWithShape="0" blurRad="127000" dist="25400" dir="5400000">
+              <a:srgbClr val="000000">
+                <a:alpha val="18000"/>
+              </a:srgbClr>
+            </a:outerShdw>
+          </a:effectLst>
+        </p:spPr>
+      </p:sp>
+      <p:sp>
+        <p:nvSpPr>
+          <p:cNvPr id="6" name="Text 4"/>
+          <p:cNvSpPr/>
+          <p:nvPr/>
+        </p:nvSpPr>
+        <p:spPr>
+          <a:xfrm>
+            <a:off x="1005840" y="3063240"/>
+            <a:ext cx="10149840" cy="1188720"/>
+          </a:xfrm>
+          <a:prstGeom prst="rect">
+            <a:avLst/>
+          </a:prstGeom>
+          <a:noFill/>
+          <a:ln/>
+        </p:spPr>
+        <p:txBody>
+          <a:bodyPr wrap="square" lIns="0" tIns="0" rIns="0" bIns="0" rtlCol="0" anchor="ctr"/>
+          <a:lstStyle/>
+          <a:p>
+            <a:pPr indent="0" marL="0">
+              <a:lnSpc>
+                <a:spcPts val="2200"/>
+              </a:lnSpc>
+              <a:buNone/>
+            </a:pPr>
+            <a:r>
+              <a:rPr lang="en-US" sz="1450" dirty="0">
+                <a:solidFill>
+                  <a:srgbClr val="5B6470"/>
+                </a:solidFill>
+                <a:latin typeface="Calibri" pitchFamily="34" charset="0"/>
+                <a:ea typeface="Calibri" pitchFamily="34" charset="-122"/>
+                <a:cs typeface="Calibri" pitchFamily="34" charset="-120"/>
+              </a:rPr>
+              <a:t>No soy un genio que lo sabe todo. Ustedes tampoco están equivocados. Es solo un idioma que yo aprendí y ustedes no — como el que no sabe de motores no entiende al mecánico, y no por eso el mecánico está loco.</a:t>
+            </a:r>
+            <a:endParaRPr lang="en-US" sz="1450" dirty="0"/>
+          </a:p>
+        </p:txBody>
+      </p:sp>
+      <p:sp>
+        <p:nvSpPr>
+          <p:cNvPr id="7" name="Shape 5"/>
+          <p:cNvSpPr/>
+          <p:nvPr/>
+        </p:nvSpPr>
+        <p:spPr>
+          <a:xfrm>
+            <a:off x="640080" y="4480560"/>
+            <a:ext cx="10881360" cy="1417320"/>
+          </a:xfrm>
+          <a:prstGeom prst="roundRect">
+            <a:avLst>
+              <a:gd name="adj" fmla="val 6452"/>
+            </a:avLst>
+          </a:prstGeom>
+          <a:solidFill>
+            <a:srgbClr val="ECE7DA"/>
+          </a:solidFill>
+          <a:ln/>
+          <a:effectLst>
+            <a:outerShdw sx="100000" sy="100000" kx="0" ky="0" algn="bl" rotWithShape="0" blurRad="127000" dist="25400" dir="5400000">
+              <a:srgbClr val="000000">
+                <a:alpha val="18000"/>
+              </a:srgbClr>
+            </a:outerShdw>
+          </a:effectLst>
+        </p:spPr>
+      </p:sp>
+      <p:sp>
+        <p:nvSpPr>
+          <p:cNvPr id="8" name="Text 6"/>
+          <p:cNvSpPr/>
+          <p:nvPr/>
+        </p:nvSpPr>
+        <p:spPr>
+          <a:xfrm>
+            <a:off x="1005840" y="4480560"/>
+            <a:ext cx="10149840" cy="1417320"/>
+          </a:xfrm>
+          <a:prstGeom prst="rect">
+            <a:avLst/>
+          </a:prstGeom>
+          <a:noFill/>
+          <a:ln/>
+        </p:spPr>
+        <p:txBody>
+          <a:bodyPr wrap="square" lIns="0" tIns="0" rIns="0" bIns="0" rtlCol="0" anchor="ctr"/>
+          <a:lstStyle/>
+          <a:p>
+            <a:pPr indent="0" marL="0">
+              <a:lnSpc>
+                <a:spcPts val="2300"/>
+              </a:lnSpc>
+              <a:buNone/>
+            </a:pPr>
+            <a:r>
+              <a:rPr lang="en-US" sz="1500" b="1" dirty="0">
+                <a:solidFill>
+                  <a:srgbClr val="1A1D23"/>
+                </a:solidFill>
+                <a:latin typeface="Calibri" pitchFamily="34" charset="0"/>
+                <a:ea typeface="Calibri" pitchFamily="34" charset="-122"/>
+                <a:cs typeface="Calibri" pitchFamily="34" charset="-120"/>
+              </a:rPr>
+              <a:t>Lo que a veces se ve como que “me cuesta arrancar” es, en realidad, estar metido de lleno en algo que nadie más aquí está haciendo. Les pido confianza mientras lo cierro. El trabajo habla por mí — y aquí está.</a:t>
+            </a:r>
+            <a:endParaRPr lang="en-US" sz="1500" dirty="0"/>
           </a:p>
         </p:txBody>
       </p:sp>

</xml_diff>